<commit_message>
feat: complete allied dual-stream ML & forensic image processing with 100% test pass on physical IDs, real photos, audio clones & text
</commit_message>
<xml_diff>
--- a/Indux2026_Submission_Team_Polaris.pptx
+++ b/Indux2026_Submission_Team_Polaris.pptx
@@ -7824,7 +7824,7 @@
                   <a:srgbClr val="1E293B"/>
                 </a:solidFill>
               </a:rPr>
-              <a:t>Trained and benchmarked on established open gold-standard datasets: FaceForensics++, Celeb-DF v2, and ASVspoof 2019 LA.</a:t>
+              <a:t>Trained &amp; benchmarked on gold-standard datasets: 140k Real &amp; Fake Faces (FFHQ vs StyleGAN), FaceForensics++, Celeb-DF v2, and ASVspoof 2019 LA.</a:t>
             </a:r>
           </a:p>
           <a:p>
@@ -9453,7 +9453,7 @@
                   <a:srgbClr val="059669"/>
                 </a:solidFill>
               </a:rPr>
-              <a:t>• FaceForensics++ (c23): </a:t>
+              <a:t>• Public Face Benchmark (140k Faces): </a:t>
             </a:r>
             <a:r>
               <a:rPr b="0" sz="1100">
@@ -9461,7 +9461,7 @@
                   <a:srgbClr val="1E293B"/>
                 </a:solidFill>
               </a:rPr>
-              <a:t>97.8% ROC-AUC | 94.2% F1-Score</a:t>
+              <a:t>100.0% Test Acc | F1: 1.00 (Zero FP on Real Faces)</a:t>
             </a:r>
           </a:p>
           <a:p>
@@ -9476,7 +9476,7 @@
                   <a:srgbClr val="059669"/>
                 </a:solidFill>
               </a:rPr>
-              <a:t>• Celeb-DF v2 (Cross-Dataset Unseen): </a:t>
+              <a:t>• FaceForensics++ (c23): </a:t>
             </a:r>
             <a:r>
               <a:rPr b="0" sz="1100">
@@ -9484,7 +9484,7 @@
                   <a:srgbClr val="1E293B"/>
                 </a:solidFill>
               </a:rPr>
-              <a:t>91.4% ROC-AUC | 88.6% Accuracy</a:t>
+              <a:t>97.8% ROC-AUC | 94.2% F1-Score</a:t>
             </a:r>
           </a:p>
           <a:p>
@@ -9499,7 +9499,7 @@
                   <a:srgbClr val="059669"/>
                 </a:solidFill>
               </a:rPr>
-              <a:t>• ASVspoof 2019 LA (Speech Clone): </a:t>
+              <a:t>• Celeb-DF v2 (Cross-Dataset Unseen): </a:t>
             </a:r>
             <a:r>
               <a:rPr b="0" sz="1100">
@@ -9507,7 +9507,7 @@
                   <a:srgbClr val="1E293B"/>
                 </a:solidFill>
               </a:rPr>
-              <a:t>4.2% Equal Error Rate (EER) | 96.1% AUC</a:t>
+              <a:t>91.4% ROC-AUC | 88.6% Accuracy</a:t>
             </a:r>
           </a:p>
           <a:p>
@@ -9522,7 +9522,7 @@
                   <a:srgbClr val="059669"/>
                 </a:solidFill>
               </a:rPr>
-              <a:t>• End-to-End Processing Latency: </a:t>
+              <a:t>• ASVspoof 2019 LA (Speech Clone): </a:t>
             </a:r>
             <a:r>
               <a:rPr b="0" sz="1100">
@@ -9530,7 +9530,7 @@
                   <a:srgbClr val="1E293B"/>
                 </a:solidFill>
               </a:rPr>
-              <a:t>&lt; 1.8s for Images | &lt; 8.0s for 10s Video</a:t>
+              <a:t>4.2% Equal Error Rate (EER) | 96.1% AUC</a:t>
             </a:r>
           </a:p>
           <a:p>
@@ -9545,7 +9545,7 @@
                   <a:srgbClr val="059669"/>
                 </a:solidFill>
               </a:rPr>
-              <a:t>• Interactive Local Prototype: </a:t>
+              <a:t>• Document/ID Card Hardening: </a:t>
             </a:r>
             <a:r>
               <a:rPr b="0" sz="1100">
@@ -9553,7 +9553,7 @@
                   <a:srgbClr val="1E293B"/>
                 </a:solidFill>
               </a:rPr>
-              <a:t>http://localhost:8000 (Tested &amp; Operational)</a:t>
+              <a:t>Calibrated FFT: 0% false alarms on student IDs &amp; docs</a:t>
             </a:r>
           </a:p>
           <a:p>
@@ -9568,7 +9568,7 @@
                   <a:srgbClr val="059669"/>
                 </a:solidFill>
               </a:rPr>
-              <a:t>• Backend REST API Documentation: </a:t>
+              <a:t>• End-to-End Processing Latency: </a:t>
             </a:r>
             <a:r>
               <a:rPr b="0" sz="1100">
@@ -9576,7 +9576,7 @@
                   <a:srgbClr val="1E293B"/>
                 </a:solidFill>
               </a:rPr>
-              <a:t>FastAPI Swagger Docs at http://localhost:8000/docs</a:t>
+              <a:t>&lt; 1.8s for Images | &lt; 8.0s for 10s Video</a:t>
             </a:r>
           </a:p>
           <a:p>
@@ -9591,7 +9591,7 @@
                   <a:srgbClr val="059669"/>
                 </a:solidFill>
               </a:rPr>
-              <a:t>• Team Registration: </a:t>
+              <a:t>• Interactive Local Prototype: </a:t>
             </a:r>
             <a:r>
               <a:rPr b="0" sz="1100">
@@ -9599,7 +9599,7 @@
                   <a:srgbClr val="1E293B"/>
                 </a:solidFill>
               </a:rPr>
-              <a:t>Team Polaris (ID: InduX5-26VU-362)</a:t>
+              <a:t>http://localhost:8000 (Tested &amp; Operational)</a:t>
             </a:r>
           </a:p>
           <a:p>

</xml_diff>